<commit_message>
Expand bilingual user guides with full walkthrough
</commit_message>
<xml_diff>
--- a/docs/FastERP_user_guide_2026-07-28.pptx
+++ b/docs/FastERP_user_guide_2026-07-28.pptx
@@ -16,6 +16,12 @@
     <p:sldId id="264" r:id="rId15"/>
     <p:sldId id="265" r:id="rId16"/>
     <p:sldId id="266" r:id="rId17"/>
+    <p:sldId id="267" r:id="rId18"/>
+    <p:sldId id="268" r:id="rId19"/>
+    <p:sldId id="269" r:id="rId20"/>
+    <p:sldId id="270" r:id="rId21"/>
+    <p:sldId id="271" r:id="rId22"/>
+    <p:sldId id="272" r:id="rId23"/>
   </p:sldIdLst>
   <p:sldSz cx="12191695" cy="6858000" type="screen4x3"/>
   <p:notesSz cx="6858000" cy="9144000"/>
@@ -3114,8 +3120,8 @@
         </p:nvSpPr>
         <p:spPr>
           <a:xfrm>
-            <a:off x="914400" y="2057400"/>
-            <a:ext cx="10332720" cy="2194560"/>
+            <a:off x="685800" y="411480"/>
+            <a:ext cx="10789920" cy="1325880"/>
           </a:xfrm>
           <a:prstGeom prst="rect">
             <a:avLst/>
@@ -3132,14 +3138,14 @@
               <a:spcAft>
                 <a:spcPts val="800"/>
               </a:spcAft>
-              <a:defRPr sz="4800" b="1">
+              <a:defRPr sz="3400" b="1">
                 <a:solidFill>
                   <a:srgbClr val="FFFFFF"/>
                 </a:solidFill>
               </a:defRPr>
             </a:pPr>
             <a:r>
-              <a:t>FastERP</a:t>
+              <a:t>FastERP User Guide</a:t>
             </a:r>
           </a:p>
           <a:p>
@@ -3147,7 +3153,7 @@
               <a:spcAft>
                 <a:spcPts val="800"/>
               </a:spcAft>
-              <a:defRPr sz="2400">
+              <a:defRPr sz="1800">
                 <a:solidFill>
                   <a:srgbClr val="FFFFFF"/>
                 </a:solidFill>
@@ -3162,7 +3168,7 @@
               <a:spcAft>
                 <a:spcPts val="800"/>
               </a:spcAft>
-              <a:defRPr sz="2400">
+              <a:defRPr sz="1800">
                 <a:solidFill>
                   <a:srgbClr val="FFFFFF"/>
                 </a:solidFill>
@@ -3174,6 +3180,30 @@
           </a:p>
         </p:txBody>
       </p:sp>
+      <p:pic>
+        <p:nvPicPr>
+          <p:cNvPr id="3" name="Picture 2" descr="01-login.png"/>
+          <p:cNvPicPr>
+            <a:picLocks noChangeAspect="1"/>
+          </p:cNvPicPr>
+          <p:nvPr/>
+        </p:nvPicPr>
+        <p:blipFill>
+          <a:blip r:embed="rId2"/>
+          <a:stretch>
+            <a:fillRect/>
+          </a:stretch>
+        </p:blipFill>
+        <p:spPr>
+          <a:xfrm>
+            <a:off x="2743200" y="1828800"/>
+            <a:ext cx="6702552" cy="3770186"/>
+          </a:xfrm>
+          <a:prstGeom prst="rect">
+            <a:avLst/>
+          </a:prstGeom>
+        </p:spPr>
+      </p:pic>
     </p:spTree>
   </p:cSld>
   <p:clrMapOvr>
@@ -3268,7 +3298,7 @@
               </a:defRPr>
             </a:pPr>
             <a:r>
-              <a:t>Explore the integration API</a:t>
+              <a:t>Chart of accounts</a:t>
             </a:r>
           </a:p>
         </p:txBody>
@@ -3306,7 +3336,7 @@
               </a:defRPr>
             </a:pPr>
             <a:r>
-              <a:t>Run the API separately:</a:t>
+              <a:t>The 22-account chart groups assets, liabilities, equity, income, cost of sales</a:t>
             </a:r>
           </a:p>
           <a:p>
@@ -3321,7 +3351,7 @@
               </a:defRPr>
             </a:pPr>
             <a:r>
-              <a:t>.venv/bin/uvicorn api_app:app --port 5012</a:t>
+              <a:t>and operating expenses. Select an account to trace its postings in the General</a:t>
             </a:r>
           </a:p>
           <a:p>
@@ -3336,59 +3366,14 @@
               </a:defRPr>
             </a:pPr>
             <a:r>
-              <a:t>Open http://localhost:5012/docs for Swagger UI. The stub exposes accounts,</a:t>
-            </a:r>
-          </a:p>
-          <a:p>
-            <a:pPr>
-              <a:spcAft>
-                <a:spcPts val="800"/>
-              </a:spcAft>
-              <a:defRPr sz="1500">
-                <a:solidFill>
-                  <a:srgbClr val="27211A"/>
-                </a:solidFill>
-              </a:defRPr>
-            </a:pPr>
-            <a:r>
-              <a:t>invoices, expenses, projects, Profit &amp; Loss, Trial Balance and a webhook example.</a:t>
-            </a:r>
-          </a:p>
-          <a:p>
-            <a:pPr>
-              <a:spcAft>
-                <a:spcPts val="800"/>
-              </a:spcAft>
-              <a:defRPr sz="1500">
-                <a:solidFill>
-                  <a:srgbClr val="27211A"/>
-                </a:solidFill>
-              </a:defRPr>
-            </a:pPr>
-            <a:r>
-              <a:t>POST /v1/invoices validates and previews a payload but deliberately does not</a:t>
-            </a:r>
-          </a:p>
-          <a:p>
-            <a:pPr>
-              <a:spcAft>
-                <a:spcPts val="800"/>
-              </a:spcAft>
-              <a:defRPr sz="1500">
-                <a:solidFill>
-                  <a:srgbClr val="27211A"/>
-                </a:solidFill>
-              </a:defRPr>
-            </a:pPr>
-            <a:r>
-              <a:t>post it. The API is a future connector boundary, not an Intuit integration.</a:t>
+              <a:t>Ledger.</a:t>
             </a:r>
           </a:p>
         </p:txBody>
       </p:sp>
       <p:pic>
         <p:nvPicPr>
-          <p:cNvPr id="5" name="Picture 4" descr="erp-11-api.png"/>
+          <p:cNvPr id="5" name="Picture 4" descr="10-accounts.png"/>
           <p:cNvPicPr>
             <a:picLocks noChangeAspect="1"/>
           </p:cNvPicPr>
@@ -3542,7 +3527,7 @@
               </a:defRPr>
             </a:pPr>
             <a:r>
-              <a:t>Verification and safety</a:t>
+              <a:t>Record an expense</a:t>
             </a:r>
           </a:p>
         </p:txBody>
@@ -3556,7 +3541,7 @@
         <p:spPr>
           <a:xfrm>
             <a:off x="502920" y="1143000"/>
-            <a:ext cx="10972800" cy="5029200"/>
+            <a:ext cx="4846320" cy="5029200"/>
           </a:xfrm>
           <a:prstGeom prst="rect">
             <a:avLst/>
@@ -3580,7 +3565,7 @@
               </a:defRPr>
             </a:pPr>
             <a:r>
-              <a:t>Run .venv/bin/python -m pytest -q before changing accounting behavior. Tests</a:t>
+              <a:t>Choose a supplier and expense category, then enter the net amount, tax code and</a:t>
             </a:r>
           </a:p>
           <a:p>
@@ -3595,7 +3580,7 @@
               </a:defRPr>
             </a:pPr>
             <a:r>
-              <a:t>assert that seeded books and new postings remain balanced, invalid journals are</a:t>
+              <a:t>currency. Optional business-unit and project dimensions flow to ledger lines and</a:t>
             </a:r>
           </a:p>
           <a:p>
@@ -3610,14 +3595,198 @@
               </a:defRPr>
             </a:pPr>
             <a:r>
-              <a:t>rejected, and API previews are non-posting.</a:t>
-            </a:r>
-          </a:p>
+              <a:t>profitability reporting. A note can retain approval or receipt context.</a:t>
+            </a:r>
+          </a:p>
+        </p:txBody>
+      </p:sp>
+      <p:pic>
+        <p:nvPicPr>
+          <p:cNvPr id="5" name="Picture 4" descr="11-expense.png"/>
+          <p:cNvPicPr>
+            <a:picLocks noChangeAspect="1"/>
+          </p:cNvPicPr>
+          <p:nvPr/>
+        </p:nvPicPr>
+        <p:blipFill>
+          <a:blip r:embed="rId2"/>
+          <a:stretch>
+            <a:fillRect/>
+          </a:stretch>
+        </p:blipFill>
+        <p:spPr>
+          <a:xfrm>
+            <a:off x="5623560" y="1234440"/>
+            <a:ext cx="6080760" cy="3420428"/>
+          </a:xfrm>
+          <a:prstGeom prst="rect">
+            <a:avLst/>
+          </a:prstGeom>
+        </p:spPr>
+      </p:pic>
+      <p:sp>
+        <p:nvSpPr>
+          <p:cNvPr id="6" name="TextBox 5"/>
+          <p:cNvSpPr txBox="1"/>
+          <p:nvPr/>
+        </p:nvSpPr>
+        <p:spPr>
+          <a:xfrm>
+            <a:off x="457200" y="6473952"/>
+            <a:ext cx="11247120" cy="228600"/>
+          </a:xfrm>
+          <a:prstGeom prst="rect">
+            <a:avLst/>
+          </a:prstGeom>
+          <a:noFill/>
+        </p:spPr>
+        <p:txBody>
+          <a:bodyPr wrap="square">
+            <a:spAutoFit/>
+          </a:bodyPr>
+          <a:lstStyle/>
+          <a:p>
+            <a:pPr algn="r">
+              <a:spcAft>
+                <a:spcPts val="800"/>
+              </a:spcAft>
+              <a:defRPr sz="800">
+                <a:solidFill>
+                  <a:srgbClr val="7C7162"/>
+                </a:solidFill>
+              </a:defRPr>
+            </a:pPr>
+            <a:r>
+              <a:t>FastERP · Synthetic accounting workspace · 2026-07-28</a:t>
+            </a:r>
+          </a:p>
+        </p:txBody>
+      </p:sp>
+    </p:spTree>
+  </p:cSld>
+  <p:clrMapOvr>
+    <a:masterClrMapping/>
+  </p:clrMapOvr>
+</p:sld>
+</file>
+
+<file path=ppt/slides/slide12.xml><?xml version="1.0" encoding="utf-8"?>
+<p:sld xmlns:a="http://schemas.openxmlformats.org/drawingml/2006/main" xmlns:p="http://schemas.openxmlformats.org/presentationml/2006/main" xmlns:r="http://schemas.openxmlformats.org/officeDocument/2006/relationships">
+  <p:cSld>
+    <p:spTree>
+      <p:nvGrpSpPr>
+        <p:cNvPr id="1" name=""/>
+        <p:cNvGrpSpPr/>
+        <p:nvPr/>
+      </p:nvGrpSpPr>
+      <p:grpSpPr/>
+      <p:sp>
+        <p:nvSpPr>
+          <p:cNvPr id="2" name="Rectangle 1"/>
+          <p:cNvSpPr/>
+          <p:nvPr/>
+        </p:nvSpPr>
+        <p:spPr>
+          <a:xfrm>
+            <a:off x="0" y="0"/>
+            <a:ext cx="12191695" cy="841248"/>
+          </a:xfrm>
+          <a:prstGeom prst="rect">
+            <a:avLst/>
+          </a:prstGeom>
+          <a:solidFill>
+            <a:srgbClr val="D97706"/>
+          </a:solidFill>
+          <a:ln>
+            <a:noFill/>
+          </a:ln>
+        </p:spPr>
+        <p:style>
+          <a:lnRef idx="1">
+            <a:schemeClr val="accent1"/>
+          </a:lnRef>
+          <a:fillRef idx="3">
+            <a:schemeClr val="accent1"/>
+          </a:fillRef>
+          <a:effectRef idx="2">
+            <a:schemeClr val="accent1"/>
+          </a:effectRef>
+          <a:fontRef idx="minor">
+            <a:schemeClr val="lt1"/>
+          </a:fontRef>
+        </p:style>
+        <p:txBody>
+          <a:bodyPr rtlCol="0" anchor="ctr"/>
+          <a:lstStyle/>
+          <a:p>
+            <a:pPr algn="ctr"/>
+          </a:p>
+        </p:txBody>
+      </p:sp>
+      <p:sp>
+        <p:nvSpPr>
+          <p:cNvPr id="3" name="TextBox 2"/>
+          <p:cNvSpPr txBox="1"/>
+          <p:nvPr/>
+        </p:nvSpPr>
+        <p:spPr>
+          <a:xfrm>
+            <a:off x="411480" y="137160"/>
+            <a:ext cx="11338560" cy="502920"/>
+          </a:xfrm>
+          <a:prstGeom prst="rect">
+            <a:avLst/>
+          </a:prstGeom>
+          <a:noFill/>
+        </p:spPr>
+        <p:txBody>
+          <a:bodyPr wrap="square">
+            <a:spAutoFit/>
+          </a:bodyPr>
+          <a:lstStyle/>
           <a:p>
             <a:pPr>
               <a:spcAft>
                 <a:spcPts val="800"/>
               </a:spcAft>
+              <a:defRPr sz="2500" b="1">
+                <a:solidFill>
+                  <a:srgbClr val="FFFFFF"/>
+                </a:solidFill>
+              </a:defRPr>
+            </a:pPr>
+            <a:r>
+              <a:t>Post a journal entry</a:t>
+            </a:r>
+          </a:p>
+        </p:txBody>
+      </p:sp>
+      <p:sp>
+        <p:nvSpPr>
+          <p:cNvPr id="4" name="TextBox 3"/>
+          <p:cNvSpPr txBox="1"/>
+          <p:nvPr/>
+        </p:nvSpPr>
+        <p:spPr>
+          <a:xfrm>
+            <a:off x="502920" y="1143000"/>
+            <a:ext cx="4846320" cy="5029200"/>
+          </a:xfrm>
+          <a:prstGeom prst="rect">
+            <a:avLst/>
+          </a:prstGeom>
+          <a:noFill/>
+        </p:spPr>
+        <p:txBody>
+          <a:bodyPr wrap="square">
+            <a:spAutoFit/>
+          </a:bodyPr>
+          <a:lstStyle/>
+          <a:p>
+            <a:pPr>
+              <a:spcAft>
+                <a:spcPts val="800"/>
+              </a:spcAft>
               <a:defRPr sz="1500">
                 <a:solidFill>
                   <a:srgbClr val="27211A"/>
@@ -3625,7 +3794,7 @@
               </a:defRPr>
             </a:pPr>
             <a:r>
-              <a:t>FastERP is a demonstration, not production accounting software. Exchange rates,</a:t>
+              <a:t>Enter a date and memo, then add at least two account lines. Each line may carry a</a:t>
             </a:r>
           </a:p>
           <a:p>
@@ -3640,7 +3809,7 @@
               </a:defRPr>
             </a:pPr>
             <a:r>
-              <a:t>tax treatment and reports are illustrative. Never replace the synthetic database</a:t>
+              <a:t>business unit and project. FastERP rejects the journal unless total debits equal</a:t>
             </a:r>
           </a:p>
           <a:p>
@@ -3655,14 +3824,1198 @@
               </a:defRPr>
             </a:pPr>
             <a:r>
-              <a:t>or receipt assets with personal, banking or customer production data.</a:t>
-            </a:r>
-          </a:p>
-        </p:txBody>
-      </p:sp>
-      <p:sp>
-        <p:nvSpPr>
-          <p:cNvPr id="5" name="TextBox 4"/>
+              <a:t>total credits.</a:t>
+            </a:r>
+          </a:p>
+        </p:txBody>
+      </p:sp>
+      <p:pic>
+        <p:nvPicPr>
+          <p:cNvPr id="5" name="Picture 4" descr="12-journal.png"/>
+          <p:cNvPicPr>
+            <a:picLocks noChangeAspect="1"/>
+          </p:cNvPicPr>
+          <p:nvPr/>
+        </p:nvPicPr>
+        <p:blipFill>
+          <a:blip r:embed="rId2"/>
+          <a:stretch>
+            <a:fillRect/>
+          </a:stretch>
+        </p:blipFill>
+        <p:spPr>
+          <a:xfrm>
+            <a:off x="5623560" y="1234440"/>
+            <a:ext cx="6080760" cy="3420428"/>
+          </a:xfrm>
+          <a:prstGeom prst="rect">
+            <a:avLst/>
+          </a:prstGeom>
+        </p:spPr>
+      </p:pic>
+      <p:sp>
+        <p:nvSpPr>
+          <p:cNvPr id="6" name="TextBox 5"/>
+          <p:cNvSpPr txBox="1"/>
+          <p:nvPr/>
+        </p:nvSpPr>
+        <p:spPr>
+          <a:xfrm>
+            <a:off x="457200" y="6473952"/>
+            <a:ext cx="11247120" cy="228600"/>
+          </a:xfrm>
+          <a:prstGeom prst="rect">
+            <a:avLst/>
+          </a:prstGeom>
+          <a:noFill/>
+        </p:spPr>
+        <p:txBody>
+          <a:bodyPr wrap="square">
+            <a:spAutoFit/>
+          </a:bodyPr>
+          <a:lstStyle/>
+          <a:p>
+            <a:pPr algn="r">
+              <a:spcAft>
+                <a:spcPts val="800"/>
+              </a:spcAft>
+              <a:defRPr sz="800">
+                <a:solidFill>
+                  <a:srgbClr val="7C7162"/>
+                </a:solidFill>
+              </a:defRPr>
+            </a:pPr>
+            <a:r>
+              <a:t>FastERP · Synthetic accounting workspace · 2026-07-28</a:t>
+            </a:r>
+          </a:p>
+        </p:txBody>
+      </p:sp>
+    </p:spTree>
+  </p:cSld>
+  <p:clrMapOvr>
+    <a:masterClrMapping/>
+  </p:clrMapOvr>
+</p:sld>
+</file>
+
+<file path=ppt/slides/slide13.xml><?xml version="1.0" encoding="utf-8"?>
+<p:sld xmlns:a="http://schemas.openxmlformats.org/drawingml/2006/main" xmlns:p="http://schemas.openxmlformats.org/presentationml/2006/main" xmlns:r="http://schemas.openxmlformats.org/officeDocument/2006/relationships">
+  <p:cSld>
+    <p:spTree>
+      <p:nvGrpSpPr>
+        <p:cNvPr id="1" name=""/>
+        <p:cNvGrpSpPr/>
+        <p:nvPr/>
+      </p:nvGrpSpPr>
+      <p:grpSpPr/>
+      <p:sp>
+        <p:nvSpPr>
+          <p:cNvPr id="2" name="Rectangle 1"/>
+          <p:cNvSpPr/>
+          <p:nvPr/>
+        </p:nvSpPr>
+        <p:spPr>
+          <a:xfrm>
+            <a:off x="0" y="0"/>
+            <a:ext cx="12191695" cy="841248"/>
+          </a:xfrm>
+          <a:prstGeom prst="rect">
+            <a:avLst/>
+          </a:prstGeom>
+          <a:solidFill>
+            <a:srgbClr val="D97706"/>
+          </a:solidFill>
+          <a:ln>
+            <a:noFill/>
+          </a:ln>
+        </p:spPr>
+        <p:style>
+          <a:lnRef idx="1">
+            <a:schemeClr val="accent1"/>
+          </a:lnRef>
+          <a:fillRef idx="3">
+            <a:schemeClr val="accent1"/>
+          </a:fillRef>
+          <a:effectRef idx="2">
+            <a:schemeClr val="accent1"/>
+          </a:effectRef>
+          <a:fontRef idx="minor">
+            <a:schemeClr val="lt1"/>
+          </a:fontRef>
+        </p:style>
+        <p:txBody>
+          <a:bodyPr rtlCol="0" anchor="ctr"/>
+          <a:lstStyle/>
+          <a:p>
+            <a:pPr algn="ctr"/>
+          </a:p>
+        </p:txBody>
+      </p:sp>
+      <p:sp>
+        <p:nvSpPr>
+          <p:cNvPr id="3" name="TextBox 2"/>
+          <p:cNvSpPr txBox="1"/>
+          <p:nvPr/>
+        </p:nvSpPr>
+        <p:spPr>
+          <a:xfrm>
+            <a:off x="411480" y="137160"/>
+            <a:ext cx="11338560" cy="502920"/>
+          </a:xfrm>
+          <a:prstGeom prst="rect">
+            <a:avLst/>
+          </a:prstGeom>
+          <a:noFill/>
+        </p:spPr>
+        <p:txBody>
+          <a:bodyPr wrap="square">
+            <a:spAutoFit/>
+          </a:bodyPr>
+          <a:lstStyle/>
+          <a:p>
+            <a:pPr>
+              <a:spcAft>
+                <a:spcPts val="800"/>
+              </a:spcAft>
+              <a:defRPr sz="2500" b="1">
+                <a:solidFill>
+                  <a:srgbClr val="FFFFFF"/>
+                </a:solidFill>
+              </a:defRPr>
+            </a:pPr>
+            <a:r>
+              <a:t>General ledger</a:t>
+            </a:r>
+          </a:p>
+        </p:txBody>
+      </p:sp>
+      <p:sp>
+        <p:nvSpPr>
+          <p:cNvPr id="4" name="TextBox 3"/>
+          <p:cNvSpPr txBox="1"/>
+          <p:nvPr/>
+        </p:nvSpPr>
+        <p:spPr>
+          <a:xfrm>
+            <a:off x="502920" y="1143000"/>
+            <a:ext cx="4846320" cy="5029200"/>
+          </a:xfrm>
+          <a:prstGeom prst="rect">
+            <a:avLst/>
+          </a:prstGeom>
+          <a:noFill/>
+        </p:spPr>
+        <p:txBody>
+          <a:bodyPr wrap="square">
+            <a:spAutoFit/>
+          </a:bodyPr>
+          <a:lstStyle/>
+          <a:p>
+            <a:pPr>
+              <a:spcAft>
+                <a:spcPts val="800"/>
+              </a:spcAft>
+              <a:defRPr sz="1500">
+                <a:solidFill>
+                  <a:srgbClr val="27211A"/>
+                </a:solidFill>
+              </a:defRPr>
+            </a:pPr>
+            <a:r>
+              <a:t>The Trial Balance summarizes debits, credits and normal-side balances. Filter</a:t>
+            </a:r>
+          </a:p>
+          <a:p>
+            <a:pPr>
+              <a:spcAft>
+                <a:spcPts val="800"/>
+              </a:spcAft>
+              <a:defRPr sz="1500">
+                <a:solidFill>
+                  <a:srgbClr val="27211A"/>
+                </a:solidFill>
+              </a:defRPr>
+            </a:pPr>
+            <a:r>
+              <a:t>ledger entries by account and use shared references such as INV-7042,</a:t>
+            </a:r>
+          </a:p>
+          <a:p>
+            <a:pPr>
+              <a:spcAft>
+                <a:spcPts val="800"/>
+              </a:spcAft>
+              <a:defRPr sz="1500">
+                <a:solidFill>
+                  <a:srgbClr val="27211A"/>
+                </a:solidFill>
+              </a:defRPr>
+            </a:pPr>
+            <a:r>
+              <a:t>EXP-8001 and JE-9001 to follow linked transactions.</a:t>
+            </a:r>
+          </a:p>
+        </p:txBody>
+      </p:sp>
+      <p:pic>
+        <p:nvPicPr>
+          <p:cNvPr id="5" name="Picture 4" descr="13-ledger.png"/>
+          <p:cNvPicPr>
+            <a:picLocks noChangeAspect="1"/>
+          </p:cNvPicPr>
+          <p:nvPr/>
+        </p:nvPicPr>
+        <p:blipFill>
+          <a:blip r:embed="rId2"/>
+          <a:stretch>
+            <a:fillRect/>
+          </a:stretch>
+        </p:blipFill>
+        <p:spPr>
+          <a:xfrm>
+            <a:off x="5623560" y="1234440"/>
+            <a:ext cx="6080760" cy="3420428"/>
+          </a:xfrm>
+          <a:prstGeom prst="rect">
+            <a:avLst/>
+          </a:prstGeom>
+        </p:spPr>
+      </p:pic>
+      <p:sp>
+        <p:nvSpPr>
+          <p:cNvPr id="6" name="TextBox 5"/>
+          <p:cNvSpPr txBox="1"/>
+          <p:nvPr/>
+        </p:nvSpPr>
+        <p:spPr>
+          <a:xfrm>
+            <a:off x="457200" y="6473952"/>
+            <a:ext cx="11247120" cy="228600"/>
+          </a:xfrm>
+          <a:prstGeom prst="rect">
+            <a:avLst/>
+          </a:prstGeom>
+          <a:noFill/>
+        </p:spPr>
+        <p:txBody>
+          <a:bodyPr wrap="square">
+            <a:spAutoFit/>
+          </a:bodyPr>
+          <a:lstStyle/>
+          <a:p>
+            <a:pPr algn="r">
+              <a:spcAft>
+                <a:spcPts val="800"/>
+              </a:spcAft>
+              <a:defRPr sz="800">
+                <a:solidFill>
+                  <a:srgbClr val="7C7162"/>
+                </a:solidFill>
+              </a:defRPr>
+            </a:pPr>
+            <a:r>
+              <a:t>FastERP · Synthetic accounting workspace · 2026-07-28</a:t>
+            </a:r>
+          </a:p>
+        </p:txBody>
+      </p:sp>
+    </p:spTree>
+  </p:cSld>
+  <p:clrMapOvr>
+    <a:masterClrMapping/>
+  </p:clrMapOvr>
+</p:sld>
+</file>
+
+<file path=ppt/slides/slide14.xml><?xml version="1.0" encoding="utf-8"?>
+<p:sld xmlns:a="http://schemas.openxmlformats.org/drawingml/2006/main" xmlns:p="http://schemas.openxmlformats.org/presentationml/2006/main" xmlns:r="http://schemas.openxmlformats.org/officeDocument/2006/relationships">
+  <p:cSld>
+    <p:spTree>
+      <p:nvGrpSpPr>
+        <p:cNvPr id="1" name=""/>
+        <p:cNvGrpSpPr/>
+        <p:nvPr/>
+      </p:nvGrpSpPr>
+      <p:grpSpPr/>
+      <p:sp>
+        <p:nvSpPr>
+          <p:cNvPr id="2" name="Rectangle 1"/>
+          <p:cNvSpPr/>
+          <p:nvPr/>
+        </p:nvSpPr>
+        <p:spPr>
+          <a:xfrm>
+            <a:off x="0" y="0"/>
+            <a:ext cx="12191695" cy="841248"/>
+          </a:xfrm>
+          <a:prstGeom prst="rect">
+            <a:avLst/>
+          </a:prstGeom>
+          <a:solidFill>
+            <a:srgbClr val="D97706"/>
+          </a:solidFill>
+          <a:ln>
+            <a:noFill/>
+          </a:ln>
+        </p:spPr>
+        <p:style>
+          <a:lnRef idx="1">
+            <a:schemeClr val="accent1"/>
+          </a:lnRef>
+          <a:fillRef idx="3">
+            <a:schemeClr val="accent1"/>
+          </a:fillRef>
+          <a:effectRef idx="2">
+            <a:schemeClr val="accent1"/>
+          </a:effectRef>
+          <a:fontRef idx="minor">
+            <a:schemeClr val="lt1"/>
+          </a:fontRef>
+        </p:style>
+        <p:txBody>
+          <a:bodyPr rtlCol="0" anchor="ctr"/>
+          <a:lstStyle/>
+          <a:p>
+            <a:pPr algn="ctr"/>
+          </a:p>
+        </p:txBody>
+      </p:sp>
+      <p:sp>
+        <p:nvSpPr>
+          <p:cNvPr id="3" name="TextBox 2"/>
+          <p:cNvSpPr txBox="1"/>
+          <p:nvPr/>
+        </p:nvSpPr>
+        <p:spPr>
+          <a:xfrm>
+            <a:off x="411480" y="137160"/>
+            <a:ext cx="11338560" cy="502920"/>
+          </a:xfrm>
+          <a:prstGeom prst="rect">
+            <a:avLst/>
+          </a:prstGeom>
+          <a:noFill/>
+        </p:spPr>
+        <p:txBody>
+          <a:bodyPr wrap="square">
+            <a:spAutoFit/>
+          </a:bodyPr>
+          <a:lstStyle/>
+          <a:p>
+            <a:pPr>
+              <a:spcAft>
+                <a:spcPts val="800"/>
+              </a:spcAft>
+              <a:defRPr sz="2500" b="1">
+                <a:solidFill>
+                  <a:srgbClr val="FFFFFF"/>
+                </a:solidFill>
+              </a:defRPr>
+            </a:pPr>
+            <a:r>
+              <a:t>Projects and business units</a:t>
+            </a:r>
+          </a:p>
+        </p:txBody>
+      </p:sp>
+      <p:sp>
+        <p:nvSpPr>
+          <p:cNvPr id="4" name="TextBox 3"/>
+          <p:cNvSpPr txBox="1"/>
+          <p:nvPr/>
+        </p:nvSpPr>
+        <p:spPr>
+          <a:xfrm>
+            <a:off x="502920" y="1143000"/>
+            <a:ext cx="4846320" cy="5029200"/>
+          </a:xfrm>
+          <a:prstGeom prst="rect">
+            <a:avLst/>
+          </a:prstGeom>
+          <a:noFill/>
+        </p:spPr>
+        <p:txBody>
+          <a:bodyPr wrap="square">
+            <a:spAutoFit/>
+          </a:bodyPr>
+          <a:lstStyle/>
+          <a:p>
+            <a:pPr>
+              <a:spcAft>
+                <a:spcPts val="800"/>
+              </a:spcAft>
+              <a:defRPr sz="1500">
+                <a:solidFill>
+                  <a:srgbClr val="27211A"/>
+                </a:solidFill>
+              </a:defRPr>
+            </a:pPr>
+            <a:r>
+              <a:t>Projects combine customer, owning business unit, status, budget, revenue, costs</a:t>
+            </a:r>
+          </a:p>
+          <a:p>
+            <a:pPr>
+              <a:spcAft>
+                <a:spcPts val="800"/>
+              </a:spcAft>
+              <a:defRPr sz="1500">
+                <a:solidFill>
+                  <a:srgbClr val="27211A"/>
+                </a:solidFill>
+              </a:defRPr>
+            </a:pPr>
+            <a:r>
+              <a:t>and margin. Dimensioned expenses and journals update project costs immediately</a:t>
+            </a:r>
+          </a:p>
+          <a:p>
+            <a:pPr>
+              <a:spcAft>
+                <a:spcPts val="800"/>
+              </a:spcAft>
+              <a:defRPr sz="1500">
+                <a:solidFill>
+                  <a:srgbClr val="27211A"/>
+                </a:solidFill>
+              </a:defRPr>
+            </a:pPr>
+            <a:r>
+              <a:t>without requiring separate ledgers.</a:t>
+            </a:r>
+          </a:p>
+        </p:txBody>
+      </p:sp>
+      <p:pic>
+        <p:nvPicPr>
+          <p:cNvPr id="5" name="Picture 4" descr="14-projects.png"/>
+          <p:cNvPicPr>
+            <a:picLocks noChangeAspect="1"/>
+          </p:cNvPicPr>
+          <p:nvPr/>
+        </p:nvPicPr>
+        <p:blipFill>
+          <a:blip r:embed="rId2"/>
+          <a:stretch>
+            <a:fillRect/>
+          </a:stretch>
+        </p:blipFill>
+        <p:spPr>
+          <a:xfrm>
+            <a:off x="5623560" y="1234440"/>
+            <a:ext cx="6080760" cy="3420428"/>
+          </a:xfrm>
+          <a:prstGeom prst="rect">
+            <a:avLst/>
+          </a:prstGeom>
+        </p:spPr>
+      </p:pic>
+      <p:sp>
+        <p:nvSpPr>
+          <p:cNvPr id="6" name="TextBox 5"/>
+          <p:cNvSpPr txBox="1"/>
+          <p:nvPr/>
+        </p:nvSpPr>
+        <p:spPr>
+          <a:xfrm>
+            <a:off x="457200" y="6473952"/>
+            <a:ext cx="11247120" cy="228600"/>
+          </a:xfrm>
+          <a:prstGeom prst="rect">
+            <a:avLst/>
+          </a:prstGeom>
+          <a:noFill/>
+        </p:spPr>
+        <p:txBody>
+          <a:bodyPr wrap="square">
+            <a:spAutoFit/>
+          </a:bodyPr>
+          <a:lstStyle/>
+          <a:p>
+            <a:pPr algn="r">
+              <a:spcAft>
+                <a:spcPts val="800"/>
+              </a:spcAft>
+              <a:defRPr sz="800">
+                <a:solidFill>
+                  <a:srgbClr val="7C7162"/>
+                </a:solidFill>
+              </a:defRPr>
+            </a:pPr>
+            <a:r>
+              <a:t>FastERP · Synthetic accounting workspace · 2026-07-28</a:t>
+            </a:r>
+          </a:p>
+        </p:txBody>
+      </p:sp>
+    </p:spTree>
+  </p:cSld>
+  <p:clrMapOvr>
+    <a:masterClrMapping/>
+  </p:clrMapOvr>
+</p:sld>
+</file>
+
+<file path=ppt/slides/slide15.xml><?xml version="1.0" encoding="utf-8"?>
+<p:sld xmlns:a="http://schemas.openxmlformats.org/drawingml/2006/main" xmlns:p="http://schemas.openxmlformats.org/presentationml/2006/main" xmlns:r="http://schemas.openxmlformats.org/officeDocument/2006/relationships">
+  <p:cSld>
+    <p:spTree>
+      <p:nvGrpSpPr>
+        <p:cNvPr id="1" name=""/>
+        <p:cNvGrpSpPr/>
+        <p:nvPr/>
+      </p:nvGrpSpPr>
+      <p:grpSpPr/>
+      <p:sp>
+        <p:nvSpPr>
+          <p:cNvPr id="2" name="Rectangle 1"/>
+          <p:cNvSpPr/>
+          <p:nvPr/>
+        </p:nvSpPr>
+        <p:spPr>
+          <a:xfrm>
+            <a:off x="0" y="0"/>
+            <a:ext cx="12191695" cy="841248"/>
+          </a:xfrm>
+          <a:prstGeom prst="rect">
+            <a:avLst/>
+          </a:prstGeom>
+          <a:solidFill>
+            <a:srgbClr val="D97706"/>
+          </a:solidFill>
+          <a:ln>
+            <a:noFill/>
+          </a:ln>
+        </p:spPr>
+        <p:style>
+          <a:lnRef idx="1">
+            <a:schemeClr val="accent1"/>
+          </a:lnRef>
+          <a:fillRef idx="3">
+            <a:schemeClr val="accent1"/>
+          </a:fillRef>
+          <a:effectRef idx="2">
+            <a:schemeClr val="accent1"/>
+          </a:effectRef>
+          <a:fontRef idx="minor">
+            <a:schemeClr val="lt1"/>
+          </a:fontRef>
+        </p:style>
+        <p:txBody>
+          <a:bodyPr rtlCol="0" anchor="ctr"/>
+          <a:lstStyle/>
+          <a:p>
+            <a:pPr algn="ctr"/>
+          </a:p>
+        </p:txBody>
+      </p:sp>
+      <p:sp>
+        <p:nvSpPr>
+          <p:cNvPr id="3" name="TextBox 2"/>
+          <p:cNvSpPr txBox="1"/>
+          <p:nvPr/>
+        </p:nvSpPr>
+        <p:spPr>
+          <a:xfrm>
+            <a:off x="411480" y="137160"/>
+            <a:ext cx="11338560" cy="502920"/>
+          </a:xfrm>
+          <a:prstGeom prst="rect">
+            <a:avLst/>
+          </a:prstGeom>
+          <a:noFill/>
+        </p:spPr>
+        <p:txBody>
+          <a:bodyPr wrap="square">
+            <a:spAutoFit/>
+          </a:bodyPr>
+          <a:lstStyle/>
+          <a:p>
+            <a:pPr>
+              <a:spcAft>
+                <a:spcPts val="800"/>
+              </a:spcAft>
+              <a:defRPr sz="2500" b="1">
+                <a:solidFill>
+                  <a:srgbClr val="FFFFFF"/>
+                </a:solidFill>
+              </a:defRPr>
+            </a:pPr>
+            <a:r>
+              <a:t>Financial reports</a:t>
+            </a:r>
+          </a:p>
+        </p:txBody>
+      </p:sp>
+      <p:sp>
+        <p:nvSpPr>
+          <p:cNvPr id="4" name="TextBox 3"/>
+          <p:cNvSpPr txBox="1"/>
+          <p:nvPr/>
+        </p:nvSpPr>
+        <p:spPr>
+          <a:xfrm>
+            <a:off x="502920" y="1143000"/>
+            <a:ext cx="4846320" cy="5029200"/>
+          </a:xfrm>
+          <a:prstGeom prst="rect">
+            <a:avLst/>
+          </a:prstGeom>
+          <a:noFill/>
+        </p:spPr>
+        <p:txBody>
+          <a:bodyPr wrap="square">
+            <a:spAutoFit/>
+          </a:bodyPr>
+          <a:lstStyle/>
+          <a:p>
+            <a:pPr>
+              <a:spcAft>
+                <a:spcPts val="800"/>
+              </a:spcAft>
+              <a:defRPr sz="1500">
+                <a:solidFill>
+                  <a:srgbClr val="27211A"/>
+                </a:solidFill>
+              </a:defRPr>
+            </a:pPr>
+            <a:r>
+              <a:t>Switch between Profit &amp; Loss, Balance Sheet, Trial Balance and Sales Tax. Reports</a:t>
+            </a:r>
+          </a:p>
+          <a:p>
+            <a:pPr>
+              <a:spcAft>
+                <a:spcPts val="800"/>
+              </a:spcAft>
+              <a:defRPr sz="1500">
+                <a:solidFill>
+                  <a:srgbClr val="27211A"/>
+                </a:solidFill>
+              </a:defRPr>
+            </a:pPr>
+            <a:r>
+              <a:t>are accrual-basis, presented in GBP and derived solely from posted double-entry</a:t>
+            </a:r>
+          </a:p>
+          <a:p>
+            <a:pPr>
+              <a:spcAft>
+                <a:spcPts val="800"/>
+              </a:spcAft>
+              <a:defRPr sz="1500">
+                <a:solidFill>
+                  <a:srgbClr val="27211A"/>
+                </a:solidFill>
+              </a:defRPr>
+            </a:pPr>
+            <a:r>
+              <a:t>transactions.</a:t>
+            </a:r>
+          </a:p>
+        </p:txBody>
+      </p:sp>
+      <p:pic>
+        <p:nvPicPr>
+          <p:cNvPr id="5" name="Picture 4" descr="15-reports.png"/>
+          <p:cNvPicPr>
+            <a:picLocks noChangeAspect="1"/>
+          </p:cNvPicPr>
+          <p:nvPr/>
+        </p:nvPicPr>
+        <p:blipFill>
+          <a:blip r:embed="rId2"/>
+          <a:stretch>
+            <a:fillRect/>
+          </a:stretch>
+        </p:blipFill>
+        <p:spPr>
+          <a:xfrm>
+            <a:off x="5623560" y="1234440"/>
+            <a:ext cx="6080760" cy="3420428"/>
+          </a:xfrm>
+          <a:prstGeom prst="rect">
+            <a:avLst/>
+          </a:prstGeom>
+        </p:spPr>
+      </p:pic>
+      <p:sp>
+        <p:nvSpPr>
+          <p:cNvPr id="6" name="TextBox 5"/>
+          <p:cNvSpPr txBox="1"/>
+          <p:nvPr/>
+        </p:nvSpPr>
+        <p:spPr>
+          <a:xfrm>
+            <a:off x="457200" y="6473952"/>
+            <a:ext cx="11247120" cy="228600"/>
+          </a:xfrm>
+          <a:prstGeom prst="rect">
+            <a:avLst/>
+          </a:prstGeom>
+          <a:noFill/>
+        </p:spPr>
+        <p:txBody>
+          <a:bodyPr wrap="square">
+            <a:spAutoFit/>
+          </a:bodyPr>
+          <a:lstStyle/>
+          <a:p>
+            <a:pPr algn="r">
+              <a:spcAft>
+                <a:spcPts val="800"/>
+              </a:spcAft>
+              <a:defRPr sz="800">
+                <a:solidFill>
+                  <a:srgbClr val="7C7162"/>
+                </a:solidFill>
+              </a:defRPr>
+            </a:pPr>
+            <a:r>
+              <a:t>FastERP · Synthetic accounting workspace · 2026-07-28</a:t>
+            </a:r>
+          </a:p>
+        </p:txBody>
+      </p:sp>
+    </p:spTree>
+  </p:cSld>
+  <p:clrMapOvr>
+    <a:masterClrMapping/>
+  </p:clrMapOvr>
+</p:sld>
+</file>
+
+<file path=ppt/slides/slide16.xml><?xml version="1.0" encoding="utf-8"?>
+<p:sld xmlns:a="http://schemas.openxmlformats.org/drawingml/2006/main" xmlns:p="http://schemas.openxmlformats.org/presentationml/2006/main" xmlns:r="http://schemas.openxmlformats.org/officeDocument/2006/relationships">
+  <p:cSld>
+    <p:spTree>
+      <p:nvGrpSpPr>
+        <p:cNvPr id="1" name=""/>
+        <p:cNvGrpSpPr/>
+        <p:nvPr/>
+      </p:nvGrpSpPr>
+      <p:grpSpPr/>
+      <p:sp>
+        <p:nvSpPr>
+          <p:cNvPr id="2" name="Rectangle 1"/>
+          <p:cNvSpPr/>
+          <p:nvPr/>
+        </p:nvSpPr>
+        <p:spPr>
+          <a:xfrm>
+            <a:off x="0" y="0"/>
+            <a:ext cx="12191695" cy="841248"/>
+          </a:xfrm>
+          <a:prstGeom prst="rect">
+            <a:avLst/>
+          </a:prstGeom>
+          <a:solidFill>
+            <a:srgbClr val="D97706"/>
+          </a:solidFill>
+          <a:ln>
+            <a:noFill/>
+          </a:ln>
+        </p:spPr>
+        <p:style>
+          <a:lnRef idx="1">
+            <a:schemeClr val="accent1"/>
+          </a:lnRef>
+          <a:fillRef idx="3">
+            <a:schemeClr val="accent1"/>
+          </a:fillRef>
+          <a:effectRef idx="2">
+            <a:schemeClr val="accent1"/>
+          </a:effectRef>
+          <a:fontRef idx="minor">
+            <a:schemeClr val="lt1"/>
+          </a:fontRef>
+        </p:style>
+        <p:txBody>
+          <a:bodyPr rtlCol="0" anchor="ctr"/>
+          <a:lstStyle/>
+          <a:p>
+            <a:pPr algn="ctr"/>
+          </a:p>
+        </p:txBody>
+      </p:sp>
+      <p:sp>
+        <p:nvSpPr>
+          <p:cNvPr id="3" name="TextBox 2"/>
+          <p:cNvSpPr txBox="1"/>
+          <p:nvPr/>
+        </p:nvSpPr>
+        <p:spPr>
+          <a:xfrm>
+            <a:off x="411480" y="137160"/>
+            <a:ext cx="11338560" cy="502920"/>
+          </a:xfrm>
+          <a:prstGeom prst="rect">
+            <a:avLst/>
+          </a:prstGeom>
+          <a:noFill/>
+        </p:spPr>
+        <p:txBody>
+          <a:bodyPr wrap="square">
+            <a:spAutoFit/>
+          </a:bodyPr>
+          <a:lstStyle/>
+          <a:p>
+            <a:pPr>
+              <a:spcAft>
+                <a:spcPts val="800"/>
+              </a:spcAft>
+              <a:defRPr sz="2500" b="1">
+                <a:solidFill>
+                  <a:srgbClr val="FFFFFF"/>
+                </a:solidFill>
+              </a:defRPr>
+            </a:pPr>
+            <a:r>
+              <a:t>Accounting setup and attachments</a:t>
+            </a:r>
+          </a:p>
+        </p:txBody>
+      </p:sp>
+      <p:sp>
+        <p:nvSpPr>
+          <p:cNvPr id="4" name="TextBox 3"/>
+          <p:cNvSpPr txBox="1"/>
+          <p:nvPr/>
+        </p:nvSpPr>
+        <p:spPr>
+          <a:xfrm>
+            <a:off x="502920" y="1143000"/>
+            <a:ext cx="4846320" cy="5029200"/>
+          </a:xfrm>
+          <a:prstGeom prst="rect">
+            <a:avLst/>
+          </a:prstGeom>
+          <a:noFill/>
+        </p:spPr>
+        <p:txBody>
+          <a:bodyPr wrap="square">
+            <a:spAutoFit/>
+          </a:bodyPr>
+          <a:lstStyle/>
+          <a:p>
+            <a:pPr>
+              <a:spcAft>
+                <a:spcPts val="800"/>
+              </a:spcAft>
+              <a:defRPr sz="1500">
+                <a:solidFill>
+                  <a:srgbClr val="27211A"/>
+                </a:solidFill>
+              </a:defRPr>
+            </a:pPr>
+            <a:r>
+              <a:t>Setup lists GBP, EUR, USD and CAD rates, tax codes, business units and synthetic</a:t>
+            </a:r>
+          </a:p>
+          <a:p>
+            <a:pPr>
+              <a:spcAft>
+                <a:spcPts val="800"/>
+              </a:spcAft>
+              <a:defRPr sz="1500">
+                <a:solidFill>
+                  <a:srgbClr val="27211A"/>
+                </a:solidFill>
+              </a:defRPr>
+            </a:pPr>
+            <a:r>
+              <a:t>receipt attachments. The rates and tax treatment are illustrative; the receipt</a:t>
+            </a:r>
+          </a:p>
+          <a:p>
+            <a:pPr>
+              <a:spcAft>
+                <a:spcPts val="800"/>
+              </a:spcAft>
+              <a:defRPr sz="1500">
+                <a:solidFill>
+                  <a:srgbClr val="27211A"/>
+                </a:solidFill>
+              </a:defRPr>
+            </a:pPr>
+            <a:r>
+              <a:t>images contain no real supplier or payment information.</a:t>
+            </a:r>
+          </a:p>
+        </p:txBody>
+      </p:sp>
+      <p:pic>
+        <p:nvPicPr>
+          <p:cNvPr id="5" name="Picture 4" descr="16-setup.png"/>
+          <p:cNvPicPr>
+            <a:picLocks noChangeAspect="1"/>
+          </p:cNvPicPr>
+          <p:nvPr/>
+        </p:nvPicPr>
+        <p:blipFill>
+          <a:blip r:embed="rId2"/>
+          <a:stretch>
+            <a:fillRect/>
+          </a:stretch>
+        </p:blipFill>
+        <p:spPr>
+          <a:xfrm>
+            <a:off x="5623560" y="1234440"/>
+            <a:ext cx="6080760" cy="3420428"/>
+          </a:xfrm>
+          <a:prstGeom prst="rect">
+            <a:avLst/>
+          </a:prstGeom>
+        </p:spPr>
+      </p:pic>
+      <p:sp>
+        <p:nvSpPr>
+          <p:cNvPr id="6" name="TextBox 5"/>
+          <p:cNvSpPr txBox="1"/>
+          <p:nvPr/>
+        </p:nvSpPr>
+        <p:spPr>
+          <a:xfrm>
+            <a:off x="457200" y="6473952"/>
+            <a:ext cx="11247120" cy="228600"/>
+          </a:xfrm>
+          <a:prstGeom prst="rect">
+            <a:avLst/>
+          </a:prstGeom>
+          <a:noFill/>
+        </p:spPr>
+        <p:txBody>
+          <a:bodyPr wrap="square">
+            <a:spAutoFit/>
+          </a:bodyPr>
+          <a:lstStyle/>
+          <a:p>
+            <a:pPr algn="r">
+              <a:spcAft>
+                <a:spcPts val="800"/>
+              </a:spcAft>
+              <a:defRPr sz="800">
+                <a:solidFill>
+                  <a:srgbClr val="7C7162"/>
+                </a:solidFill>
+              </a:defRPr>
+            </a:pPr>
+            <a:r>
+              <a:t>FastERP · Synthetic accounting workspace · 2026-07-28</a:t>
+            </a:r>
+          </a:p>
+        </p:txBody>
+      </p:sp>
+    </p:spTree>
+  </p:cSld>
+  <p:clrMapOvr>
+    <a:masterClrMapping/>
+  </p:clrMapOvr>
+</p:sld>
+</file>
+
+<file path=ppt/slides/slide17.xml><?xml version="1.0" encoding="utf-8"?>
+<p:sld xmlns:a="http://schemas.openxmlformats.org/drawingml/2006/main" xmlns:p="http://schemas.openxmlformats.org/presentationml/2006/main" xmlns:r="http://schemas.openxmlformats.org/officeDocument/2006/relationships">
+  <p:cSld>
+    <p:spTree>
+      <p:nvGrpSpPr>
+        <p:cNvPr id="1" name=""/>
+        <p:cNvGrpSpPr/>
+        <p:nvPr/>
+      </p:nvGrpSpPr>
+      <p:grpSpPr/>
+      <p:sp>
+        <p:nvSpPr>
+          <p:cNvPr id="2" name="Rectangle 1"/>
+          <p:cNvSpPr/>
+          <p:nvPr/>
+        </p:nvSpPr>
+        <p:spPr>
+          <a:xfrm>
+            <a:off x="0" y="0"/>
+            <a:ext cx="12191695" cy="841248"/>
+          </a:xfrm>
+          <a:prstGeom prst="rect">
+            <a:avLst/>
+          </a:prstGeom>
+          <a:solidFill>
+            <a:srgbClr val="D97706"/>
+          </a:solidFill>
+          <a:ln>
+            <a:noFill/>
+          </a:ln>
+        </p:spPr>
+        <p:style>
+          <a:lnRef idx="1">
+            <a:schemeClr val="accent1"/>
+          </a:lnRef>
+          <a:fillRef idx="3">
+            <a:schemeClr val="accent1"/>
+          </a:fillRef>
+          <a:effectRef idx="2">
+            <a:schemeClr val="accent1"/>
+          </a:effectRef>
+          <a:fontRef idx="minor">
+            <a:schemeClr val="lt1"/>
+          </a:fontRef>
+        </p:style>
+        <p:txBody>
+          <a:bodyPr rtlCol="0" anchor="ctr"/>
+          <a:lstStyle/>
+          <a:p>
+            <a:pPr algn="ctr"/>
+          </a:p>
+        </p:txBody>
+      </p:sp>
+      <p:sp>
+        <p:nvSpPr>
+          <p:cNvPr id="3" name="TextBox 2"/>
+          <p:cNvSpPr txBox="1"/>
+          <p:nvPr/>
+        </p:nvSpPr>
+        <p:spPr>
+          <a:xfrm>
+            <a:off x="411480" y="137160"/>
+            <a:ext cx="11338560" cy="502920"/>
+          </a:xfrm>
+          <a:prstGeom prst="rect">
+            <a:avLst/>
+          </a:prstGeom>
+          <a:noFill/>
+        </p:spPr>
+        <p:txBody>
+          <a:bodyPr wrap="square">
+            <a:spAutoFit/>
+          </a:bodyPr>
+          <a:lstStyle/>
+          <a:p>
+            <a:pPr>
+              <a:spcAft>
+                <a:spcPts val="800"/>
+              </a:spcAft>
+              <a:defRPr sz="2500" b="1">
+                <a:solidFill>
+                  <a:srgbClr val="FFFFFF"/>
+                </a:solidFill>
+              </a:defRPr>
+            </a:pPr>
+            <a:r>
+              <a:t>Integration API and Swagger</a:t>
+            </a:r>
+          </a:p>
+        </p:txBody>
+      </p:sp>
+      <p:sp>
+        <p:nvSpPr>
+          <p:cNvPr id="4" name="TextBox 3"/>
+          <p:cNvSpPr txBox="1"/>
+          <p:nvPr/>
+        </p:nvSpPr>
+        <p:spPr>
+          <a:xfrm>
+            <a:off x="502920" y="1143000"/>
+            <a:ext cx="4846320" cy="5029200"/>
+          </a:xfrm>
+          <a:prstGeom prst="rect">
+            <a:avLst/>
+          </a:prstGeom>
+          <a:noFill/>
+        </p:spPr>
+        <p:txBody>
+          <a:bodyPr wrap="square">
+            <a:spAutoFit/>
+          </a:bodyPr>
+          <a:lstStyle/>
+          <a:p>
+            <a:pPr>
+              <a:spcAft>
+                <a:spcPts val="800"/>
+              </a:spcAft>
+              <a:defRPr sz="1500">
+                <a:solidFill>
+                  <a:srgbClr val="27211A"/>
+                </a:solidFill>
+              </a:defRPr>
+            </a:pPr>
+            <a:r>
+              <a:t>Run .venv/bin/uvicorn api_app:app --port 5012 and open</a:t>
+            </a:r>
+          </a:p>
+          <a:p>
+            <a:pPr>
+              <a:spcAft>
+                <a:spcPts val="800"/>
+              </a:spcAft>
+              <a:defRPr sz="1500">
+                <a:solidFill>
+                  <a:srgbClr val="27211A"/>
+                </a:solidFill>
+              </a:defRPr>
+            </a:pPr>
+            <a:r>
+              <a:t>http://localhost:5012/docs. The read-mostly FastAPI stub documents accounts,</a:t>
+            </a:r>
+          </a:p>
+          <a:p>
+            <a:pPr>
+              <a:spcAft>
+                <a:spcPts val="800"/>
+              </a:spcAft>
+              <a:defRPr sz="1500">
+                <a:solidFill>
+                  <a:srgbClr val="27211A"/>
+                </a:solidFill>
+              </a:defRPr>
+            </a:pPr>
+            <a:r>
+              <a:t>invoices, expenses, projects, reports and webhook examples. Invoice POSTs</a:t>
+            </a:r>
+          </a:p>
+          <a:p>
+            <a:pPr>
+              <a:spcAft>
+                <a:spcPts val="800"/>
+              </a:spcAft>
+              <a:defRPr sz="1500">
+                <a:solidFill>
+                  <a:srgbClr val="27211A"/>
+                </a:solidFill>
+              </a:defRPr>
+            </a:pPr>
+            <a:r>
+              <a:t>validate previews without posting to the books.</a:t>
+            </a:r>
+          </a:p>
+        </p:txBody>
+      </p:sp>
+      <p:pic>
+        <p:nvPicPr>
+          <p:cNvPr id="5" name="Picture 4" descr="17-api.png"/>
+          <p:cNvPicPr>
+            <a:picLocks noChangeAspect="1"/>
+          </p:cNvPicPr>
+          <p:nvPr/>
+        </p:nvPicPr>
+        <p:blipFill>
+          <a:blip r:embed="rId2"/>
+          <a:stretch>
+            <a:fillRect/>
+          </a:stretch>
+        </p:blipFill>
+        <p:spPr>
+          <a:xfrm>
+            <a:off x="5623560" y="1234440"/>
+            <a:ext cx="6080760" cy="3420428"/>
+          </a:xfrm>
+          <a:prstGeom prst="rect">
+            <a:avLst/>
+          </a:prstGeom>
+        </p:spPr>
+      </p:pic>
+      <p:sp>
+        <p:nvSpPr>
+          <p:cNvPr id="6" name="TextBox 5"/>
           <p:cNvSpPr txBox="1"/>
           <p:nvPr/>
         </p:nvSpPr>
@@ -3792,7 +5145,7 @@
               </a:defRPr>
             </a:pPr>
             <a:r>
-              <a:t>Start FastERP</a:t>
+              <a:t>Operations dashboard</a:t>
             </a:r>
           </a:p>
         </p:txBody>
@@ -3806,7 +5159,7 @@
         <p:spPr>
           <a:xfrm>
             <a:off x="502920" y="1143000"/>
-            <a:ext cx="10972800" cy="5029200"/>
+            <a:ext cx="4846320" cy="5029200"/>
           </a:xfrm>
           <a:prstGeom prst="rect">
             <a:avLst/>
@@ -3830,7 +5183,7 @@
               </a:defRPr>
             </a:pPr>
             <a:r>
-              <a:t>python -m venv .venv</a:t>
+              <a:t>Start at the daily cockpit for paid revenue, receivables, inventory value and</a:t>
             </a:r>
           </a:p>
           <a:p>
@@ -3845,7 +5198,7 @@
               </a:defRPr>
             </a:pPr>
             <a:r>
-              <a:t>.venv/bin/python -m pip install -r requirements.txt</a:t>
+              <a:t>open orders. The charts highlight order status, aging debt and low-stock items.</a:t>
             </a:r>
           </a:p>
           <a:p>
@@ -3860,59 +5213,38 @@
               </a:defRPr>
             </a:pPr>
             <a:r>
-              <a:t>cp .env.sample .env</a:t>
-            </a:r>
-          </a:p>
-          <a:p>
-            <a:pPr>
-              <a:spcAft>
-                <a:spcPts val="800"/>
-              </a:spcAft>
-              <a:defRPr sz="1500">
-                <a:solidFill>
-                  <a:srgbClr val="27211A"/>
-                </a:solidFill>
-              </a:defRPr>
-            </a:pPr>
-            <a:r>
-              <a:t>.venv/bin/python seed.py</a:t>
-            </a:r>
-          </a:p>
-          <a:p>
-            <a:pPr>
-              <a:spcAft>
-                <a:spcPts val="800"/>
-              </a:spcAft>
-              <a:defRPr sz="1500">
-                <a:solidFill>
-                  <a:srgbClr val="27211A"/>
-                </a:solidFill>
-              </a:defRPr>
-            </a:pPr>
-            <a:r>
-              <a:t>.venv/bin/python web_app.py</a:t>
-            </a:r>
-          </a:p>
-          <a:p>
-            <a:pPr>
-              <a:spcAft>
-                <a:spcPts val="800"/>
-              </a:spcAft>
-              <a:defRPr sz="1500">
-                <a:solidFill>
-                  <a:srgbClr val="27211A"/>
-                </a:solidFill>
-              </a:defRPr>
-            </a:pPr>
-            <a:r>
-              <a:t>Open http://localhost:5011 and sign in as</a:t>
-            </a:r>
-          </a:p>
-        </p:txBody>
-      </p:sp>
-      <p:sp>
-        <p:nvSpPr>
-          <p:cNvPr id="5" name="TextBox 4"/>
+              <a:t>Collapse the AI rail whenever you need a wider working area.</a:t>
+            </a:r>
+          </a:p>
+        </p:txBody>
+      </p:sp>
+      <p:pic>
+        <p:nvPicPr>
+          <p:cNvPr id="5" name="Picture 4" descr="02-dashboard.png"/>
+          <p:cNvPicPr>
+            <a:picLocks noChangeAspect="1"/>
+          </p:cNvPicPr>
+          <p:nvPr/>
+        </p:nvPicPr>
+        <p:blipFill>
+          <a:blip r:embed="rId2"/>
+          <a:stretch>
+            <a:fillRect/>
+          </a:stretch>
+        </p:blipFill>
+        <p:spPr>
+          <a:xfrm>
+            <a:off x="5623560" y="1234440"/>
+            <a:ext cx="6080760" cy="3420428"/>
+          </a:xfrm>
+          <a:prstGeom prst="rect">
+            <a:avLst/>
+          </a:prstGeom>
+        </p:spPr>
+      </p:pic>
+      <p:sp>
+        <p:nvSpPr>
+          <p:cNvPr id="6" name="TextBox 5"/>
           <p:cNvSpPr txBox="1"/>
           <p:nvPr/>
         </p:nvSpPr>
@@ -4042,7 +5374,7 @@
               </a:defRPr>
             </a:pPr>
             <a:r>
-              <a:t>Accounting overview</a:t>
+              <a:t>Sales orders</a:t>
             </a:r>
           </a:p>
         </p:txBody>
@@ -4080,7 +5412,7 @@
               </a:defRPr>
             </a:pPr>
             <a:r>
-              <a:t>Open Accounting → Overview for the finance cockpit. The KPI row summarizes</a:t>
+              <a:t>Open Selling → Sales Orders to filter the order book by status or search for</a:t>
             </a:r>
           </a:p>
           <a:p>
@@ -4095,7 +5427,7 @@
               </a:defRPr>
             </a:pPr>
             <a:r>
-              <a:t>cash and bank, receivables, payables and net income. Below it, review the current</a:t>
+              <a:t>a customer or reference. Each row exposes delivery timing, workflow state and</a:t>
             </a:r>
           </a:p>
           <a:p>
@@ -4110,44 +5442,14 @@
               </a:defRPr>
             </a:pPr>
             <a:r>
-              <a:t>profit-and-loss snapshot, active projects and latest ledger postings.</a:t>
-            </a:r>
-          </a:p>
-          <a:p>
-            <a:pPr>
-              <a:spcAft>
-                <a:spcPts val="800"/>
-              </a:spcAft>
-              <a:defRPr sz="1500">
-                <a:solidFill>
-                  <a:srgbClr val="27211A"/>
-                </a:solidFill>
-              </a:defRPr>
-            </a:pPr>
-            <a:r>
-              <a:t>Use New expense for supplier costs and Journal entry for controlled</a:t>
-            </a:r>
-          </a:p>
-          <a:p>
-            <a:pPr>
-              <a:spcAft>
-                <a:spcPts val="800"/>
-              </a:spcAft>
-              <a:defRPr sz="1500">
-                <a:solidFill>
-                  <a:srgbClr val="27211A"/>
-                </a:solidFill>
-              </a:defRPr>
-            </a:pPr>
-            <a:r>
-              <a:t>adjustments. Every posted workflow writes balanced debit and credit lines.</a:t>
+              <a:t>total value.</a:t>
             </a:r>
           </a:p>
         </p:txBody>
       </p:sp>
       <p:pic>
         <p:nvPicPr>
-          <p:cNvPr id="5" name="Picture 4" descr="erp-06-accounting.png"/>
+          <p:cNvPr id="5" name="Picture 4" descr="03-orders.png"/>
           <p:cNvPicPr>
             <a:picLocks noChangeAspect="1"/>
           </p:cNvPicPr>
@@ -4301,7 +5603,7 @@
               </a:defRPr>
             </a:pPr>
             <a:r>
-              <a:t>Record a categorized expense</a:t>
+              <a:t>Order-to-cash workflow</a:t>
             </a:r>
           </a:p>
         </p:txBody>
@@ -4339,7 +5641,7 @@
               </a:defRPr>
             </a:pPr>
             <a:r>
-              <a:t>Choose a supplier and expense account, then enter the net amount. Select a tax</a:t>
+              <a:t>An order detail page combines customer data, line items, totals and the next</a:t>
             </a:r>
           </a:p>
           <a:p>
@@ -4354,7 +5656,7 @@
               </a:defRPr>
             </a:pPr>
             <a:r>
-              <a:t>code and transaction currency; FastERP converts the posting to GBP using the</a:t>
+              <a:t>transactional action. Move eligible orders through Confirm, Deliver and Invoice;</a:t>
             </a:r>
           </a:p>
           <a:p>
@@ -4369,59 +5671,14 @@
               </a:defRPr>
             </a:pPr>
             <a:r>
-              <a:t>seeded rate while retaining the source currency.</a:t>
-            </a:r>
-          </a:p>
-          <a:p>
-            <a:pPr>
-              <a:spcAft>
-                <a:spcPts val="800"/>
-              </a:spcAft>
-              <a:defRPr sz="1500">
-                <a:solidFill>
-                  <a:srgbClr val="27211A"/>
-                </a:solidFill>
-              </a:defRPr>
-            </a:pPr>
-            <a:r>
-              <a:t>Optionally assign a business unit and project. These dimensions flow to</a:t>
-            </a:r>
-          </a:p>
-          <a:p>
-            <a:pPr>
-              <a:spcAft>
-                <a:spcPts val="800"/>
-              </a:spcAft>
-              <a:defRPr sz="1500">
-                <a:solidFill>
-                  <a:srgbClr val="27211A"/>
-                </a:solidFill>
-              </a:defRPr>
-            </a:pPr>
-            <a:r>
-              <a:t>the ledger and project profitability report. Add an approval or receipt note,</a:t>
-            </a:r>
-          </a:p>
-          <a:p>
-            <a:pPr>
-              <a:spcAft>
-                <a:spcPts val="800"/>
-              </a:spcAft>
-              <a:defRPr sz="1500">
-                <a:solidFill>
-                  <a:srgbClr val="27211A"/>
-                </a:solidFill>
-              </a:defRPr>
-            </a:pPr>
-            <a:r>
-              <a:t>then select Post expense.</a:t>
+              <a:t>delivery adjusts stock and invoicing creates balanced accounting entries.</a:t>
             </a:r>
           </a:p>
         </p:txBody>
       </p:sp>
       <p:pic>
         <p:nvPicPr>
-          <p:cNvPr id="5" name="Picture 4" descr="erp-07-expense.png"/>
+          <p:cNvPr id="5" name="Picture 4" descr="04-order-detail.png"/>
           <p:cNvPicPr>
             <a:picLocks noChangeAspect="1"/>
           </p:cNvPicPr>
@@ -4575,7 +5832,7 @@
               </a:defRPr>
             </a:pPr>
             <a:r>
-              <a:t>Post a journal entry</a:t>
+              <a:t>Invoices and receivables</a:t>
             </a:r>
           </a:p>
         </p:txBody>
@@ -4589,7 +5846,7 @@
         <p:spPr>
           <a:xfrm>
             <a:off x="502920" y="1143000"/>
-            <a:ext cx="10972800" cy="5029200"/>
+            <a:ext cx="4846320" cy="5029200"/>
           </a:xfrm>
           <a:prstGeom prst="rect">
             <a:avLst/>
@@ -4613,7 +5870,7 @@
               </a:defRPr>
             </a:pPr>
             <a:r>
-              <a:t>• Select an account.</a:t>
+              <a:t>Use Invoices (AR) to review outstanding, partly paid, paid and overdue</a:t>
             </a:r>
           </a:p>
           <a:p>
@@ -4628,7 +5885,7 @@
               </a:defRPr>
             </a:pPr>
             <a:r>
-              <a:t>• Enter either a debit or credit.</a:t>
+              <a:t>invoices. Record a payment from an order or invoice workflow to clear Accounts</a:t>
             </a:r>
           </a:p>
           <a:p>
@@ -4643,29 +5900,38 @@
               </a:defRPr>
             </a:pPr>
             <a:r>
-              <a:t>• Optionally allocate the line to a business unit and project.</a:t>
-            </a:r>
-          </a:p>
-          <a:p>
-            <a:pPr>
-              <a:spcAft>
-                <a:spcPts val="800"/>
-              </a:spcAft>
-              <a:defRPr sz="1500">
-                <a:solidFill>
-                  <a:srgbClr val="27211A"/>
-                </a:solidFill>
-              </a:defRPr>
-            </a:pPr>
-            <a:r>
-              <a:t>• Confirm total debits equal total credits.</a:t>
-            </a:r>
-          </a:p>
-        </p:txBody>
-      </p:sp>
-      <p:sp>
-        <p:nvSpPr>
-          <p:cNvPr id="5" name="TextBox 4"/>
+              <a:t>Receivable and increase Cash.</a:t>
+            </a:r>
+          </a:p>
+        </p:txBody>
+      </p:sp>
+      <p:pic>
+        <p:nvPicPr>
+          <p:cNvPr id="5" name="Picture 4" descr="05-invoices.png"/>
+          <p:cNvPicPr>
+            <a:picLocks noChangeAspect="1"/>
+          </p:cNvPicPr>
+          <p:nvPr/>
+        </p:nvPicPr>
+        <p:blipFill>
+          <a:blip r:embed="rId2"/>
+          <a:stretch>
+            <a:fillRect/>
+          </a:stretch>
+        </p:blipFill>
+        <p:spPr>
+          <a:xfrm>
+            <a:off x="5623560" y="1234440"/>
+            <a:ext cx="6080760" cy="3420428"/>
+          </a:xfrm>
+          <a:prstGeom prst="rect">
+            <a:avLst/>
+          </a:prstGeom>
+        </p:spPr>
+      </p:pic>
+      <p:sp>
+        <p:nvSpPr>
+          <p:cNvPr id="6" name="TextBox 5"/>
           <p:cNvSpPr txBox="1"/>
           <p:nvPr/>
         </p:nvSpPr>
@@ -4795,7 +6061,7 @@
               </a:defRPr>
             </a:pPr>
             <a:r>
-              <a:t>Review projects and business units</a:t>
+              <a:t>Items and stock</a:t>
             </a:r>
           </a:p>
         </p:txBody>
@@ -4833,7 +6099,7 @@
               </a:defRPr>
             </a:pPr>
             <a:r>
-              <a:t>The Projects page combines customer, owning business unit, status, budget,</a:t>
+              <a:t>The stock register shows item codes, groups, selling rates, quantities, values</a:t>
             </a:r>
           </a:p>
           <a:p>
@@ -4848,7 +6114,7 @@
               </a:defRPr>
             </a:pPr>
             <a:r>
-              <a:t>revenue, costs and margin. Expense and journal allocations update costs</a:t>
+              <a:t>and reorder status. Filter by item group or search the catalog to investigate</a:t>
             </a:r>
           </a:p>
           <a:p>
@@ -4863,59 +6129,14 @@
               </a:defRPr>
             </a:pPr>
             <a:r>
-              <a:t>immediately.</a:t>
-            </a:r>
-          </a:p>
-          <a:p>
-            <a:pPr>
-              <a:spcAft>
-                <a:spcPts val="800"/>
-              </a:spcAft>
-              <a:defRPr sz="1500">
-                <a:solidFill>
-                  <a:srgbClr val="27211A"/>
-                </a:solidFill>
-              </a:defRPr>
-            </a:pPr>
-            <a:r>
-              <a:t>The synthetic setup includes UK Operations, Continental Europe and North</a:t>
-            </a:r>
-          </a:p>
-          <a:p>
-            <a:pPr>
-              <a:spcAft>
-                <a:spcPts val="800"/>
-              </a:spcAft>
-              <a:defRPr sz="1500">
-                <a:solidFill>
-                  <a:srgbClr val="27211A"/>
-                </a:solidFill>
-              </a:defRPr>
-            </a:pPr>
-            <a:r>
-              <a:t>America. Use these dimensions to compare operational areas without creating</a:t>
-            </a:r>
-          </a:p>
-          <a:p>
-            <a:pPr>
-              <a:spcAft>
-                <a:spcPts val="800"/>
-              </a:spcAft>
-              <a:defRPr sz="1500">
-                <a:solidFill>
-                  <a:srgbClr val="27211A"/>
-                </a:solidFill>
-              </a:defRPr>
-            </a:pPr>
-            <a:r>
-              <a:t>separate ledgers.</a:t>
+              <a:t>availability before confirming demand.</a:t>
             </a:r>
           </a:p>
         </p:txBody>
       </p:sp>
       <p:pic>
         <p:nvPicPr>
-          <p:cNvPr id="5" name="Picture 4" descr="erp-08-projects.png"/>
+          <p:cNvPr id="5" name="Picture 4" descr="06-items.png"/>
           <p:cNvPicPr>
             <a:picLocks noChangeAspect="1"/>
           </p:cNvPicPr>
@@ -5069,7 +6290,7 @@
               </a:defRPr>
             </a:pPr>
             <a:r>
-              <a:t>Run financial reports</a:t>
+              <a:t>Suppliers</a:t>
             </a:r>
           </a:p>
         </p:txBody>
@@ -5107,7 +6328,7 @@
               </a:defRPr>
             </a:pPr>
             <a:r>
-              <a:t>• Profit &amp; Loss — income, cost of goods sold, operating expenses and result.</a:t>
+              <a:t>The supplier register summarizes territory, purchase-order count and total</a:t>
             </a:r>
           </a:p>
           <a:p>
@@ -5122,44 +6343,14 @@
               </a:defRPr>
             </a:pPr>
             <a:r>
-              <a:t>• Balance Sheet — assets, liabilities and equity.</a:t>
-            </a:r>
-          </a:p>
-          <a:p>
-            <a:pPr>
-              <a:spcAft>
-                <a:spcPts val="800"/>
-              </a:spcAft>
-              <a:defRPr sz="1500">
-                <a:solidFill>
-                  <a:srgbClr val="27211A"/>
-                </a:solidFill>
-              </a:defRPr>
-            </a:pPr>
-            <a:r>
-              <a:t>• Trial Balance — account debits, credits and normal-side balances.</a:t>
-            </a:r>
-          </a:p>
-          <a:p>
-            <a:pPr>
-              <a:spcAft>
-                <a:spcPts val="800"/>
-              </a:spcAft>
-              <a:defRPr sz="1500">
-                <a:solidFill>
-                  <a:srgbClr val="27211A"/>
-                </a:solidFill>
-              </a:defRPr>
-            </a:pPr>
-            <a:r>
-              <a:t>• Sales Tax — taxable purchases and input tax by period.</a:t>
+              <a:t>spend. Add synthetic suppliers here before creating a purchasing transaction.</a:t>
             </a:r>
           </a:p>
         </p:txBody>
       </p:sp>
       <p:pic>
         <p:nvPicPr>
-          <p:cNvPr id="5" name="Picture 4" descr="erp-09-reports.png"/>
+          <p:cNvPr id="5" name="Picture 4" descr="07-suppliers.png"/>
           <p:cNvPicPr>
             <a:picLocks noChangeAspect="1"/>
           </p:cNvPicPr>
@@ -5313,7 +6504,7 @@
               </a:defRPr>
             </a:pPr>
             <a:r>
-              <a:t>Configure accounting dimensions</a:t>
+              <a:t>Purchase order and goods receipt</a:t>
             </a:r>
           </a:p>
         </p:txBody>
@@ -5351,7 +6542,7 @@
               </a:defRPr>
             </a:pPr>
             <a:r>
-              <a:t>• GBP, EUR, USD and CAD exchange rates.</a:t>
+              <a:t>A purchase order records supplier, line items and workflow status. Receiving an</a:t>
             </a:r>
           </a:p>
           <a:p>
@@ -5366,7 +6557,7 @@
               </a:defRPr>
             </a:pPr>
             <a:r>
-              <a:t>• UK, EU and North America business units.</a:t>
+              <a:t>ordered PO increases stock and posts Inventory against Accounts Payable, linking</a:t>
             </a:r>
           </a:p>
           <a:p>
@@ -5381,29 +6572,14 @@
               </a:defRPr>
             </a:pPr>
             <a:r>
-              <a:t>• zero, exempt, reduced and standard VAT codes.</a:t>
-            </a:r>
-          </a:p>
-          <a:p>
-            <a:pPr>
-              <a:spcAft>
-                <a:spcPts val="800"/>
-              </a:spcAft>
-              <a:defRPr sz="1500">
-                <a:solidFill>
-                  <a:srgbClr val="27211A"/>
-                </a:solidFill>
-              </a:defRPr>
-            </a:pPr>
-            <a:r>
-              <a:t>• synthetic receipt images and notes.</a:t>
+              <a:t>procurement to the general ledger.</a:t>
             </a:r>
           </a:p>
         </p:txBody>
       </p:sp>
       <p:pic>
         <p:nvPicPr>
-          <p:cNvPr id="5" name="Picture 4" descr="erp-10-setup.png"/>
+          <p:cNvPr id="5" name="Picture 4" descr="08-purchase-order.png"/>
           <p:cNvPicPr>
             <a:picLocks noChangeAspect="1"/>
           </p:cNvPicPr>
@@ -5557,7 +6733,7 @@
               </a:defRPr>
             </a:pPr>
             <a:r>
-              <a:t>Follow linked operational transactions</a:t>
+              <a:t>Accounting overview</a:t>
             </a:r>
           </a:p>
         </p:txBody>
@@ -5571,7 +6747,7 @@
         <p:spPr>
           <a:xfrm>
             <a:off x="502920" y="1143000"/>
-            <a:ext cx="10972800" cy="5029200"/>
+            <a:ext cx="4846320" cy="5029200"/>
           </a:xfrm>
           <a:prstGeom prst="rect">
             <a:avLst/>
@@ -5595,7 +6771,7 @@
               </a:defRPr>
             </a:pPr>
             <a:r>
-              <a:t>Sales invoices post Accounts Receivable, Sales Revenue, Cost of Goods Sold and</a:t>
+              <a:t>Open Accounting → Overview for cash, receivables, payables and net income.</a:t>
             </a:r>
           </a:p>
           <a:p>
@@ -5610,7 +6786,7 @@
               </a:defRPr>
             </a:pPr>
             <a:r>
-              <a:t>Inventory. Recording payment moves the balance from Accounts Receivable to</a:t>
+              <a:t>Review the Profit &amp; Loss snapshot, active projects and latest postings, or start</a:t>
             </a:r>
           </a:p>
           <a:p>
@@ -5625,59 +6801,38 @@
               </a:defRPr>
             </a:pPr>
             <a:r>
-              <a:t>Cash. Receiving a purchase order increases Inventory and Accounts Payable.</a:t>
-            </a:r>
-          </a:p>
-          <a:p>
-            <a:pPr>
-              <a:spcAft>
-                <a:spcPts val="800"/>
-              </a:spcAft>
-              <a:defRPr sz="1500">
-                <a:solidFill>
-                  <a:srgbClr val="27211A"/>
-                </a:solidFill>
-              </a:defRPr>
-            </a:pPr>
-            <a:r>
-              <a:t>Use General Ledger to filter an account and trace the shared transaction</a:t>
-            </a:r>
-          </a:p>
-          <a:p>
-            <a:pPr>
-              <a:spcAft>
-                <a:spcPts val="800"/>
-              </a:spcAft>
-              <a:defRPr sz="1500">
-                <a:solidFill>
-                  <a:srgbClr val="27211A"/>
-                </a:solidFill>
-              </a:defRPr>
-            </a:pPr>
-            <a:r>
-              <a:t>reference, such as INV-7042, PO-6018, EXP-8001 or JE-9001. This creates a</a:t>
-            </a:r>
-          </a:p>
-          <a:p>
-            <a:pPr>
-              <a:spcAft>
-                <a:spcPts val="800"/>
-              </a:spcAft>
-              <a:defRPr sz="1500">
-                <a:solidFill>
-                  <a:srgbClr val="27211A"/>
-                </a:solidFill>
-              </a:defRPr>
-            </a:pPr>
-            <a:r>
-              <a:t>clear audit trail between operational workflows and accounting.</a:t>
-            </a:r>
-          </a:p>
-        </p:txBody>
-      </p:sp>
-      <p:sp>
-        <p:nvSpPr>
-          <p:cNvPr id="5" name="TextBox 4"/>
+              <a:t>a new expense or manual journal.</a:t>
+            </a:r>
+          </a:p>
+        </p:txBody>
+      </p:sp>
+      <p:pic>
+        <p:nvPicPr>
+          <p:cNvPr id="5" name="Picture 4" descr="09-accounting.png"/>
+          <p:cNvPicPr>
+            <a:picLocks noChangeAspect="1"/>
+          </p:cNvPicPr>
+          <p:nvPr/>
+        </p:nvPicPr>
+        <p:blipFill>
+          <a:blip r:embed="rId2"/>
+          <a:stretch>
+            <a:fillRect/>
+          </a:stretch>
+        </p:blipFill>
+        <p:spPr>
+          <a:xfrm>
+            <a:off x="5623560" y="1234440"/>
+            <a:ext cx="6080760" cy="3420428"/>
+          </a:xfrm>
+          <a:prstGeom prst="rect">
+            <a:avLst/>
+          </a:prstGeom>
+        </p:spPr>
+      </p:pic>
+      <p:sp>
+        <p:nvSpPr>
+          <p:cNvPr id="6" name="TextBox 5"/>
           <p:cNvSpPr txBox="1"/>
           <p:nvPr/>
         </p:nvSpPr>

</xml_diff>